<commit_message>
Updated materials, making space for SHSn ready to teach.
</commit_message>
<xml_diff>
--- a/Day 1 Part 2/D1P2.pptx
+++ b/Day 1 Part 2/D1P2.pptx
@@ -25,8 +25,8 @@
     <p:sldId id="488" r:id="rId16"/>
     <p:sldId id="489" r:id="rId17"/>
     <p:sldId id="539" r:id="rId18"/>
-    <p:sldId id="490" r:id="rId19"/>
-    <p:sldId id="536" r:id="rId20"/>
+    <p:sldId id="536" r:id="rId19"/>
+    <p:sldId id="490" r:id="rId20"/>
     <p:sldId id="491" r:id="rId21"/>
     <p:sldId id="492" r:id="rId22"/>
     <p:sldId id="493" r:id="rId23"/>
@@ -182,8 +182,8 @@
             <p14:sldId id="488"/>
             <p14:sldId id="489"/>
             <p14:sldId id="539"/>
+            <p14:sldId id="536"/>
             <p14:sldId id="490"/>
-            <p14:sldId id="536"/>
             <p14:sldId id="491"/>
             <p14:sldId id="492"/>
             <p14:sldId id="493"/>
@@ -232,251 +232,23 @@
 </p188:authorLst>
 </file>
 
-<file path=ppt/revisionInfo.xml><?xml version="1.0" encoding="utf-8"?>
-<p1510:revInfo xmlns:a="http://schemas.openxmlformats.org/drawingml/2006/main" xmlns:r="http://schemas.openxmlformats.org/officeDocument/2006/relationships" xmlns:p1510="http://schemas.microsoft.com/office/powerpoint/2015/10/main">
-  <p1510:revLst>
-    <p1510:client id="{0B65995D-043C-4711-8235-9EAC059FDCF9}" v="99" dt="2026-01-09T01:51:12.342"/>
-  </p1510:revLst>
-</p1510:revInfo>
-</file>
-
 <file path=ppt/changesInfos/changesInfo1.xml><?xml version="1.0" encoding="utf-8"?>
 <pc:chgInfo xmlns:a="http://schemas.openxmlformats.org/drawingml/2006/main" xmlns:r="http://schemas.openxmlformats.org/officeDocument/2006/relationships" xmlns:ac="http://schemas.microsoft.com/office/drawing/2013/main/command" xmlns:pc="http://schemas.microsoft.com/office/powerpoint/2013/main/command">
   <pc:docChgLst>
     <pc:chgData name="Matthieu De Mari" userId="dfb708c9-d8dc-439f-9a3b-c772bf4a311c" providerId="ADAL" clId="{81E9B007-0C2C-493E-9B93-55A62C9C1F12}"/>
     <pc:docChg chg="undo custSel addSld delSld modSld sldOrd modSection">
-      <pc:chgData name="Matthieu De Mari" userId="dfb708c9-d8dc-439f-9a3b-c772bf4a311c" providerId="ADAL" clId="{81E9B007-0C2C-493E-9B93-55A62C9C1F12}" dt="2026-01-09T01:51:14.074" v="978" actId="20577"/>
+      <pc:chgData name="Matthieu De Mari" userId="dfb708c9-d8dc-439f-9a3b-c772bf4a311c" providerId="ADAL" clId="{81E9B007-0C2C-493E-9B93-55A62C9C1F12}" dt="2026-03-15T14:21:58.264" v="1065" actId="20577"/>
       <pc:docMkLst>
         <pc:docMk/>
       </pc:docMkLst>
-      <pc:sldChg chg="modSp mod">
-        <pc:chgData name="Matthieu De Mari" userId="dfb708c9-d8dc-439f-9a3b-c772bf4a311c" providerId="ADAL" clId="{81E9B007-0C2C-493E-9B93-55A62C9C1F12}" dt="2026-01-08T10:04:53.036" v="411" actId="113"/>
-        <pc:sldMkLst>
-          <pc:docMk/>
-          <pc:sldMk cId="3442501962" sldId="257"/>
-        </pc:sldMkLst>
-        <pc:spChg chg="mod">
-          <ac:chgData name="Matthieu De Mari" userId="dfb708c9-d8dc-439f-9a3b-c772bf4a311c" providerId="ADAL" clId="{81E9B007-0C2C-493E-9B93-55A62C9C1F12}" dt="2026-01-08T10:04:27.135" v="404" actId="20577"/>
-          <ac:spMkLst>
-            <pc:docMk/>
-            <pc:sldMk cId="3442501962" sldId="257"/>
-            <ac:spMk id="2" creationId="{49D40417-A4D3-4CE8-96E7-708E2439AE7B}"/>
-          </ac:spMkLst>
-        </pc:spChg>
-        <pc:spChg chg="mod">
-          <ac:chgData name="Matthieu De Mari" userId="dfb708c9-d8dc-439f-9a3b-c772bf4a311c" providerId="ADAL" clId="{81E9B007-0C2C-493E-9B93-55A62C9C1F12}" dt="2026-01-08T10:04:53.036" v="411" actId="113"/>
-          <ac:spMkLst>
-            <pc:docMk/>
-            <pc:sldMk cId="3442501962" sldId="257"/>
-            <ac:spMk id="3" creationId="{35995840-A9D9-479A-A34F-EA7DC229D38E}"/>
-          </ac:spMkLst>
-        </pc:spChg>
-      </pc:sldChg>
-      <pc:sldChg chg="modSp mod">
-        <pc:chgData name="Matthieu De Mari" userId="dfb708c9-d8dc-439f-9a3b-c772bf4a311c" providerId="ADAL" clId="{81E9B007-0C2C-493E-9B93-55A62C9C1F12}" dt="2026-01-09T01:51:14.074" v="978" actId="20577"/>
-        <pc:sldMkLst>
-          <pc:docMk/>
-          <pc:sldMk cId="1040156172" sldId="377"/>
-        </pc:sldMkLst>
-        <pc:spChg chg="mod">
-          <ac:chgData name="Matthieu De Mari" userId="dfb708c9-d8dc-439f-9a3b-c772bf4a311c" providerId="ADAL" clId="{81E9B007-0C2C-493E-9B93-55A62C9C1F12}" dt="2026-01-09T01:51:14.074" v="978" actId="20577"/>
-          <ac:spMkLst>
-            <pc:docMk/>
-            <pc:sldMk cId="1040156172" sldId="377"/>
-            <ac:spMk id="2" creationId="{080CEB46-CC16-4D19-8C2C-AEE9471D8168}"/>
-          </ac:spMkLst>
-        </pc:spChg>
-      </pc:sldChg>
-      <pc:sldChg chg="modSp mod">
-        <pc:chgData name="Matthieu De Mari" userId="dfb708c9-d8dc-439f-9a3b-c772bf4a311c" providerId="ADAL" clId="{81E9B007-0C2C-493E-9B93-55A62C9C1F12}" dt="2026-01-08T10:16:07.541" v="933" actId="20577"/>
-        <pc:sldMkLst>
-          <pc:docMk/>
-          <pc:sldMk cId="1377302654" sldId="412"/>
-        </pc:sldMkLst>
-        <pc:spChg chg="mod">
-          <ac:chgData name="Matthieu De Mari" userId="dfb708c9-d8dc-439f-9a3b-c772bf4a311c" providerId="ADAL" clId="{81E9B007-0C2C-493E-9B93-55A62C9C1F12}" dt="2026-01-08T10:16:07.541" v="933" actId="20577"/>
-          <ac:spMkLst>
-            <pc:docMk/>
-            <pc:sldMk cId="1377302654" sldId="412"/>
-            <ac:spMk id="3" creationId="{7BDE96C0-465C-7952-04EA-C267AC8BF678}"/>
-          </ac:spMkLst>
-        </pc:spChg>
-        <pc:spChg chg="mod">
-          <ac:chgData name="Matthieu De Mari" userId="dfb708c9-d8dc-439f-9a3b-c772bf4a311c" providerId="ADAL" clId="{81E9B007-0C2C-493E-9B93-55A62C9C1F12}" dt="2025-12-18T21:19:07.628" v="309" actId="20577"/>
-          <ac:spMkLst>
-            <pc:docMk/>
-            <pc:sldMk cId="1377302654" sldId="412"/>
-            <ac:spMk id="4" creationId="{5E76589E-870E-419D-CF95-4309EACDB190}"/>
-          </ac:spMkLst>
-        </pc:spChg>
-      </pc:sldChg>
-      <pc:sldChg chg="modSp mod">
-        <pc:chgData name="Matthieu De Mari" userId="dfb708c9-d8dc-439f-9a3b-c772bf4a311c" providerId="ADAL" clId="{81E9B007-0C2C-493E-9B93-55A62C9C1F12}" dt="2026-01-09T01:50:36.630" v="967" actId="20577"/>
-        <pc:sldMkLst>
-          <pc:docMk/>
-          <pc:sldMk cId="2981077995" sldId="474"/>
-        </pc:sldMkLst>
-        <pc:spChg chg="mod">
-          <ac:chgData name="Matthieu De Mari" userId="dfb708c9-d8dc-439f-9a3b-c772bf4a311c" providerId="ADAL" clId="{81E9B007-0C2C-493E-9B93-55A62C9C1F12}" dt="2026-01-09T01:50:36.630" v="967" actId="20577"/>
-          <ac:spMkLst>
-            <pc:docMk/>
-            <pc:sldMk cId="2981077995" sldId="474"/>
-            <ac:spMk id="2" creationId="{A51540BB-97C7-1060-F5DD-F4A4417D2522}"/>
-          </ac:spMkLst>
-        </pc:spChg>
-      </pc:sldChg>
-      <pc:sldChg chg="modSp del mod">
-        <pc:chgData name="Matthieu De Mari" userId="dfb708c9-d8dc-439f-9a3b-c772bf4a311c" providerId="ADAL" clId="{81E9B007-0C2C-493E-9B93-55A62C9C1F12}" dt="2026-01-08T10:07:06.623" v="474" actId="47"/>
-        <pc:sldMkLst>
-          <pc:docMk/>
-          <pc:sldMk cId="3169960838" sldId="475"/>
-        </pc:sldMkLst>
-        <pc:spChg chg="mod">
-          <ac:chgData name="Matthieu De Mari" userId="dfb708c9-d8dc-439f-9a3b-c772bf4a311c" providerId="ADAL" clId="{81E9B007-0C2C-493E-9B93-55A62C9C1F12}" dt="2026-01-08T10:05:31.762" v="454" actId="27636"/>
-          <ac:spMkLst>
-            <pc:docMk/>
-            <pc:sldMk cId="3169960838" sldId="475"/>
-            <ac:spMk id="3" creationId="{09ACEEFD-8460-F540-F80C-BEACC2297773}"/>
-          </ac:spMkLst>
-        </pc:spChg>
-      </pc:sldChg>
-      <pc:sldChg chg="modSp mod">
-        <pc:chgData name="Matthieu De Mari" userId="dfb708c9-d8dc-439f-9a3b-c772bf4a311c" providerId="ADAL" clId="{81E9B007-0C2C-493E-9B93-55A62C9C1F12}" dt="2026-01-08T10:07:33.213" v="511" actId="20577"/>
-        <pc:sldMkLst>
-          <pc:docMk/>
-          <pc:sldMk cId="1739226965" sldId="476"/>
-        </pc:sldMkLst>
-        <pc:spChg chg="mod">
-          <ac:chgData name="Matthieu De Mari" userId="dfb708c9-d8dc-439f-9a3b-c772bf4a311c" providerId="ADAL" clId="{81E9B007-0C2C-493E-9B93-55A62C9C1F12}" dt="2026-01-08T10:07:33.213" v="511" actId="20577"/>
-          <ac:spMkLst>
-            <pc:docMk/>
-            <pc:sldMk cId="1739226965" sldId="476"/>
-            <ac:spMk id="2" creationId="{A51540BB-97C7-1060-F5DD-F4A4417D2522}"/>
-          </ac:spMkLst>
-        </pc:spChg>
-        <pc:spChg chg="mod">
-          <ac:chgData name="Matthieu De Mari" userId="dfb708c9-d8dc-439f-9a3b-c772bf4a311c" providerId="ADAL" clId="{81E9B007-0C2C-493E-9B93-55A62C9C1F12}" dt="2026-01-08T10:07:24.635" v="487" actId="20577"/>
-          <ac:spMkLst>
-            <pc:docMk/>
-            <pc:sldMk cId="1739226965" sldId="476"/>
-            <ac:spMk id="3" creationId="{09ACEEFD-8460-F540-F80C-BEACC2297773}"/>
-          </ac:spMkLst>
-        </pc:spChg>
-      </pc:sldChg>
-      <pc:sldChg chg="modSp mod">
-        <pc:chgData name="Matthieu De Mari" userId="dfb708c9-d8dc-439f-9a3b-c772bf4a311c" providerId="ADAL" clId="{81E9B007-0C2C-493E-9B93-55A62C9C1F12}" dt="2026-01-08T10:08:47.032" v="568" actId="20577"/>
-        <pc:sldMkLst>
-          <pc:docMk/>
-          <pc:sldMk cId="1268927889" sldId="477"/>
-        </pc:sldMkLst>
-        <pc:spChg chg="mod">
-          <ac:chgData name="Matthieu De Mari" userId="dfb708c9-d8dc-439f-9a3b-c772bf4a311c" providerId="ADAL" clId="{81E9B007-0C2C-493E-9B93-55A62C9C1F12}" dt="2026-01-08T10:07:42.095" v="512"/>
-          <ac:spMkLst>
-            <pc:docMk/>
-            <pc:sldMk cId="1268927889" sldId="477"/>
-            <ac:spMk id="2" creationId="{A51540BB-97C7-1060-F5DD-F4A4417D2522}"/>
-          </ac:spMkLst>
-        </pc:spChg>
-        <pc:spChg chg="mod">
-          <ac:chgData name="Matthieu De Mari" userId="dfb708c9-d8dc-439f-9a3b-c772bf4a311c" providerId="ADAL" clId="{81E9B007-0C2C-493E-9B93-55A62C9C1F12}" dt="2026-01-08T10:08:47.032" v="568" actId="20577"/>
-          <ac:spMkLst>
-            <pc:docMk/>
-            <pc:sldMk cId="1268927889" sldId="477"/>
-            <ac:spMk id="3" creationId="{09ACEEFD-8460-F540-F80C-BEACC2297773}"/>
-          </ac:spMkLst>
-        </pc:spChg>
-      </pc:sldChg>
-      <pc:sldChg chg="modSp ord">
-        <pc:chgData name="Matthieu De Mari" userId="dfb708c9-d8dc-439f-9a3b-c772bf4a311c" providerId="ADAL" clId="{81E9B007-0C2C-493E-9B93-55A62C9C1F12}" dt="2026-01-08T10:07:08.824" v="476"/>
-        <pc:sldMkLst>
-          <pc:docMk/>
-          <pc:sldMk cId="4248348938" sldId="478"/>
-        </pc:sldMkLst>
-        <pc:spChg chg="mod">
-          <ac:chgData name="Matthieu De Mari" userId="dfb708c9-d8dc-439f-9a3b-c772bf4a311c" providerId="ADAL" clId="{81E9B007-0C2C-493E-9B93-55A62C9C1F12}" dt="2026-01-08T10:06:40.699" v="473" actId="20577"/>
-          <ac:spMkLst>
-            <pc:docMk/>
-            <pc:sldMk cId="4248348938" sldId="478"/>
-            <ac:spMk id="3" creationId="{09ACEEFD-8460-F540-F80C-BEACC2297773}"/>
-          </ac:spMkLst>
-        </pc:spChg>
-      </pc:sldChg>
-      <pc:sldChg chg="modSp mod">
-        <pc:chgData name="Matthieu De Mari" userId="dfb708c9-d8dc-439f-9a3b-c772bf4a311c" providerId="ADAL" clId="{81E9B007-0C2C-493E-9B93-55A62C9C1F12}" dt="2026-01-08T10:09:19.240" v="569" actId="14100"/>
-        <pc:sldMkLst>
-          <pc:docMk/>
-          <pc:sldMk cId="3819655263" sldId="482"/>
-        </pc:sldMkLst>
-        <pc:spChg chg="mod">
-          <ac:chgData name="Matthieu De Mari" userId="dfb708c9-d8dc-439f-9a3b-c772bf4a311c" providerId="ADAL" clId="{81E9B007-0C2C-493E-9B93-55A62C9C1F12}" dt="2026-01-08T10:09:19.240" v="569" actId="14100"/>
-          <ac:spMkLst>
-            <pc:docMk/>
-            <pc:sldMk cId="3819655263" sldId="482"/>
-            <ac:spMk id="8" creationId="{5BEF22B4-109D-679B-56C6-BF8C9EA81DAD}"/>
-          </ac:spMkLst>
-        </pc:spChg>
-      </pc:sldChg>
-      <pc:sldChg chg="modSp mod">
-        <pc:chgData name="Matthieu De Mari" userId="dfb708c9-d8dc-439f-9a3b-c772bf4a311c" providerId="ADAL" clId="{81E9B007-0C2C-493E-9B93-55A62C9C1F12}" dt="2026-01-08T10:09:46.797" v="570" actId="14100"/>
-        <pc:sldMkLst>
-          <pc:docMk/>
-          <pc:sldMk cId="4187092969" sldId="486"/>
-        </pc:sldMkLst>
-        <pc:spChg chg="mod">
-          <ac:chgData name="Matthieu De Mari" userId="dfb708c9-d8dc-439f-9a3b-c772bf4a311c" providerId="ADAL" clId="{81E9B007-0C2C-493E-9B93-55A62C9C1F12}" dt="2026-01-08T10:09:46.797" v="570" actId="14100"/>
-          <ac:spMkLst>
-            <pc:docMk/>
-            <pc:sldMk cId="4187092969" sldId="486"/>
-            <ac:spMk id="11" creationId="{CB693548-F6EE-8552-D1CD-B1EEB33BC591}"/>
-          </ac:spMkLst>
-        </pc:spChg>
-      </pc:sldChg>
-      <pc:sldChg chg="addSp delSp modSp mod">
-        <pc:chgData name="Matthieu De Mari" userId="dfb708c9-d8dc-439f-9a3b-c772bf4a311c" providerId="ADAL" clId="{81E9B007-0C2C-493E-9B93-55A62C9C1F12}" dt="2026-01-08T10:09:57.391" v="572"/>
-        <pc:sldMkLst>
-          <pc:docMk/>
-          <pc:sldMk cId="990517089" sldId="487"/>
-        </pc:sldMkLst>
-        <pc:spChg chg="del">
-          <ac:chgData name="Matthieu De Mari" userId="dfb708c9-d8dc-439f-9a3b-c772bf4a311c" providerId="ADAL" clId="{81E9B007-0C2C-493E-9B93-55A62C9C1F12}" dt="2026-01-08T10:09:56.737" v="571" actId="478"/>
-          <ac:spMkLst>
-            <pc:docMk/>
-            <pc:sldMk cId="990517089" sldId="487"/>
-            <ac:spMk id="5" creationId="{EE0568AC-DCA0-63B7-9EE3-65ABDDC04E97}"/>
-          </ac:spMkLst>
-        </pc:spChg>
-        <pc:spChg chg="add mod">
-          <ac:chgData name="Matthieu De Mari" userId="dfb708c9-d8dc-439f-9a3b-c772bf4a311c" providerId="ADAL" clId="{81E9B007-0C2C-493E-9B93-55A62C9C1F12}" dt="2026-01-08T10:09:57.391" v="572"/>
-          <ac:spMkLst>
-            <pc:docMk/>
-            <pc:sldMk cId="990517089" sldId="487"/>
-            <ac:spMk id="6" creationId="{B525AF95-89E9-76DF-4901-8EFFEB14DBA8}"/>
-          </ac:spMkLst>
-        </pc:spChg>
-      </pc:sldChg>
-      <pc:sldChg chg="modSp">
-        <pc:chgData name="Matthieu De Mari" userId="dfb708c9-d8dc-439f-9a3b-c772bf4a311c" providerId="ADAL" clId="{81E9B007-0C2C-493E-9B93-55A62C9C1F12}" dt="2025-12-18T21:15:13.020" v="269"/>
-        <pc:sldMkLst>
-          <pc:docMk/>
-          <pc:sldMk cId="658215501" sldId="489"/>
-        </pc:sldMkLst>
-        <pc:spChg chg="mod">
-          <ac:chgData name="Matthieu De Mari" userId="dfb708c9-d8dc-439f-9a3b-c772bf4a311c" providerId="ADAL" clId="{81E9B007-0C2C-493E-9B93-55A62C9C1F12}" dt="2025-12-18T21:15:13.020" v="269"/>
-          <ac:spMkLst>
-            <pc:docMk/>
-            <pc:sldMk cId="658215501" sldId="489"/>
-            <ac:spMk id="6" creationId="{3FF27FA6-234D-EB6E-7AD4-4E52F151A639}"/>
-          </ac:spMkLst>
-        </pc:spChg>
-      </pc:sldChg>
-      <pc:sldChg chg="modSp mod">
-        <pc:chgData name="Matthieu De Mari" userId="dfb708c9-d8dc-439f-9a3b-c772bf4a311c" providerId="ADAL" clId="{81E9B007-0C2C-493E-9B93-55A62C9C1F12}" dt="2026-01-08T10:12:07.546" v="734" actId="20577"/>
+      <pc:sldChg chg="modSp mod ord">
+        <pc:chgData name="Matthieu De Mari" userId="dfb708c9-d8dc-439f-9a3b-c772bf4a311c" providerId="ADAL" clId="{81E9B007-0C2C-493E-9B93-55A62C9C1F12}" dt="2026-03-15T14:21:58.264" v="1065" actId="20577"/>
         <pc:sldMkLst>
           <pc:docMk/>
           <pc:sldMk cId="1974002731" sldId="490"/>
         </pc:sldMkLst>
         <pc:spChg chg="mod">
-          <ac:chgData name="Matthieu De Mari" userId="dfb708c9-d8dc-439f-9a3b-c772bf4a311c" providerId="ADAL" clId="{81E9B007-0C2C-493E-9B93-55A62C9C1F12}" dt="2026-01-08T10:12:07.546" v="734" actId="20577"/>
+          <ac:chgData name="Matthieu De Mari" userId="dfb708c9-d8dc-439f-9a3b-c772bf4a311c" providerId="ADAL" clId="{81E9B007-0C2C-493E-9B93-55A62C9C1F12}" dt="2026-03-15T14:21:58.264" v="1065" actId="20577"/>
           <ac:spMkLst>
             <pc:docMk/>
             <pc:sldMk cId="1974002731" sldId="490"/>
@@ -484,7 +256,7 @@
           </ac:spMkLst>
         </pc:spChg>
         <pc:spChg chg="mod">
-          <ac:chgData name="Matthieu De Mari" userId="dfb708c9-d8dc-439f-9a3b-c772bf4a311c" providerId="ADAL" clId="{81E9B007-0C2C-493E-9B93-55A62C9C1F12}" dt="2026-01-08T10:12:05.826" v="730" actId="27636"/>
+          <ac:chgData name="Matthieu De Mari" userId="dfb708c9-d8dc-439f-9a3b-c772bf4a311c" providerId="ADAL" clId="{81E9B007-0C2C-493E-9B93-55A62C9C1F12}" dt="2026-03-15T14:21:37.629" v="1031" actId="27636"/>
           <ac:spMkLst>
             <pc:docMk/>
             <pc:sldMk cId="1974002731" sldId="490"/>
@@ -493,257 +265,17 @@
         </pc:spChg>
       </pc:sldChg>
       <pc:sldChg chg="modSp mod">
-        <pc:chgData name="Matthieu De Mari" userId="dfb708c9-d8dc-439f-9a3b-c772bf4a311c" providerId="ADAL" clId="{81E9B007-0C2C-493E-9B93-55A62C9C1F12}" dt="2026-01-08T10:13:01.226" v="827" actId="20577"/>
-        <pc:sldMkLst>
-          <pc:docMk/>
-          <pc:sldMk cId="3913805124" sldId="491"/>
-        </pc:sldMkLst>
-        <pc:spChg chg="mod">
-          <ac:chgData name="Matthieu De Mari" userId="dfb708c9-d8dc-439f-9a3b-c772bf4a311c" providerId="ADAL" clId="{81E9B007-0C2C-493E-9B93-55A62C9C1F12}" dt="2026-01-08T10:13:01.226" v="827" actId="20577"/>
-          <ac:spMkLst>
-            <pc:docMk/>
-            <pc:sldMk cId="3913805124" sldId="491"/>
-            <ac:spMk id="6" creationId="{3FF27FA6-234D-EB6E-7AD4-4E52F151A639}"/>
-          </ac:spMkLst>
-        </pc:spChg>
-      </pc:sldChg>
-      <pc:sldChg chg="modSp mod">
-        <pc:chgData name="Matthieu De Mari" userId="dfb708c9-d8dc-439f-9a3b-c772bf4a311c" providerId="ADAL" clId="{81E9B007-0C2C-493E-9B93-55A62C9C1F12}" dt="2026-01-08T10:13:41.974" v="886"/>
-        <pc:sldMkLst>
-          <pc:docMk/>
-          <pc:sldMk cId="1249800631" sldId="492"/>
-        </pc:sldMkLst>
-        <pc:spChg chg="mod">
-          <ac:chgData name="Matthieu De Mari" userId="dfb708c9-d8dc-439f-9a3b-c772bf4a311c" providerId="ADAL" clId="{81E9B007-0C2C-493E-9B93-55A62C9C1F12}" dt="2026-01-08T10:13:41.974" v="886"/>
-          <ac:spMkLst>
-            <pc:docMk/>
-            <pc:sldMk cId="1249800631" sldId="492"/>
-            <ac:spMk id="2" creationId="{37C84060-31A2-3AFB-B38D-81D7652356D5}"/>
-          </ac:spMkLst>
-        </pc:spChg>
-        <pc:spChg chg="mod">
-          <ac:chgData name="Matthieu De Mari" userId="dfb708c9-d8dc-439f-9a3b-c772bf4a311c" providerId="ADAL" clId="{81E9B007-0C2C-493E-9B93-55A62C9C1F12}" dt="2026-01-08T10:13:08.850" v="834" actId="27636"/>
-          <ac:spMkLst>
-            <pc:docMk/>
-            <pc:sldMk cId="1249800631" sldId="492"/>
-            <ac:spMk id="6" creationId="{3FF27FA6-234D-EB6E-7AD4-4E52F151A639}"/>
-          </ac:spMkLst>
-        </pc:spChg>
-      </pc:sldChg>
-      <pc:sldChg chg="modSp mod">
-        <pc:chgData name="Matthieu De Mari" userId="dfb708c9-d8dc-439f-9a3b-c772bf4a311c" providerId="ADAL" clId="{81E9B007-0C2C-493E-9B93-55A62C9C1F12}" dt="2026-01-08T10:14:28.012" v="907" actId="20577"/>
-        <pc:sldMkLst>
-          <pc:docMk/>
-          <pc:sldMk cId="2138921819" sldId="493"/>
-        </pc:sldMkLst>
-        <pc:spChg chg="mod">
-          <ac:chgData name="Matthieu De Mari" userId="dfb708c9-d8dc-439f-9a3b-c772bf4a311c" providerId="ADAL" clId="{81E9B007-0C2C-493E-9B93-55A62C9C1F12}" dt="2026-01-08T10:14:28.012" v="907" actId="20577"/>
-          <ac:spMkLst>
-            <pc:docMk/>
-            <pc:sldMk cId="2138921819" sldId="493"/>
-            <ac:spMk id="3" creationId="{420487D3-EA12-DF6F-4A31-967FCF611809}"/>
-          </ac:spMkLst>
-        </pc:spChg>
-      </pc:sldChg>
-      <pc:sldChg chg="modSp mod">
-        <pc:chgData name="Matthieu De Mari" userId="dfb708c9-d8dc-439f-9a3b-c772bf4a311c" providerId="ADAL" clId="{81E9B007-0C2C-493E-9B93-55A62C9C1F12}" dt="2025-12-18T21:15:36.357" v="273" actId="207"/>
-        <pc:sldMkLst>
-          <pc:docMk/>
-          <pc:sldMk cId="410904367" sldId="494"/>
-        </pc:sldMkLst>
-        <pc:spChg chg="mod">
-          <ac:chgData name="Matthieu De Mari" userId="dfb708c9-d8dc-439f-9a3b-c772bf4a311c" providerId="ADAL" clId="{81E9B007-0C2C-493E-9B93-55A62C9C1F12}" dt="2025-12-18T21:15:36.357" v="273" actId="207"/>
-          <ac:spMkLst>
-            <pc:docMk/>
-            <pc:sldMk cId="410904367" sldId="494"/>
-            <ac:spMk id="4" creationId="{27242388-4C68-D772-1E59-FC76EBC6F2CF}"/>
-          </ac:spMkLst>
-        </pc:spChg>
-      </pc:sldChg>
-      <pc:sldChg chg="modSp mod">
-        <pc:chgData name="Matthieu De Mari" userId="dfb708c9-d8dc-439f-9a3b-c772bf4a311c" providerId="ADAL" clId="{81E9B007-0C2C-493E-9B93-55A62C9C1F12}" dt="2025-12-18T21:18:27.617" v="293" actId="20577"/>
-        <pc:sldMkLst>
-          <pc:docMk/>
-          <pc:sldMk cId="2145508996" sldId="501"/>
-        </pc:sldMkLst>
-        <pc:spChg chg="mod">
-          <ac:chgData name="Matthieu De Mari" userId="dfb708c9-d8dc-439f-9a3b-c772bf4a311c" providerId="ADAL" clId="{81E9B007-0C2C-493E-9B93-55A62C9C1F12}" dt="2025-12-18T21:18:27.617" v="293" actId="20577"/>
-          <ac:spMkLst>
-            <pc:docMk/>
-            <pc:sldMk cId="2145508996" sldId="501"/>
-            <ac:spMk id="3" creationId="{5DAEE9F3-874A-926F-2B55-5B076C48EFE9}"/>
-          </ac:spMkLst>
-        </pc:spChg>
-      </pc:sldChg>
-      <pc:sldChg chg="modSp mod">
-        <pc:chgData name="Matthieu De Mari" userId="dfb708c9-d8dc-439f-9a3b-c772bf4a311c" providerId="ADAL" clId="{81E9B007-0C2C-493E-9B93-55A62C9C1F12}" dt="2026-01-08T10:15:44.026" v="909" actId="20577"/>
-        <pc:sldMkLst>
-          <pc:docMk/>
-          <pc:sldMk cId="2411344912" sldId="502"/>
-        </pc:sldMkLst>
-        <pc:spChg chg="mod">
-          <ac:chgData name="Matthieu De Mari" userId="dfb708c9-d8dc-439f-9a3b-c772bf4a311c" providerId="ADAL" clId="{81E9B007-0C2C-493E-9B93-55A62C9C1F12}" dt="2026-01-08T10:15:44.026" v="909" actId="20577"/>
-          <ac:spMkLst>
-            <pc:docMk/>
-            <pc:sldMk cId="2411344912" sldId="502"/>
-            <ac:spMk id="6" creationId="{E104F76B-BBAC-9021-8132-85B53E4D630A}"/>
-          </ac:spMkLst>
-        </pc:spChg>
-      </pc:sldChg>
-      <pc:sldChg chg="modSp mod">
-        <pc:chgData name="Matthieu De Mari" userId="dfb708c9-d8dc-439f-9a3b-c772bf4a311c" providerId="ADAL" clId="{81E9B007-0C2C-493E-9B93-55A62C9C1F12}" dt="2025-12-18T21:21:41.840" v="389" actId="20577"/>
-        <pc:sldMkLst>
-          <pc:docMk/>
-          <pc:sldMk cId="1757057001" sldId="504"/>
-        </pc:sldMkLst>
-        <pc:spChg chg="mod">
-          <ac:chgData name="Matthieu De Mari" userId="dfb708c9-d8dc-439f-9a3b-c772bf4a311c" providerId="ADAL" clId="{81E9B007-0C2C-493E-9B93-55A62C9C1F12}" dt="2025-12-18T21:21:41.840" v="389" actId="20577"/>
-          <ac:spMkLst>
-            <pc:docMk/>
-            <pc:sldMk cId="1757057001" sldId="504"/>
-            <ac:spMk id="7" creationId="{A0D24550-75E0-C992-DC9E-D60538DBA84C}"/>
-          </ac:spMkLst>
-        </pc:spChg>
-      </pc:sldChg>
-      <pc:sldChg chg="modSp mod">
-        <pc:chgData name="Matthieu De Mari" userId="dfb708c9-d8dc-439f-9a3b-c772bf4a311c" providerId="ADAL" clId="{81E9B007-0C2C-493E-9B93-55A62C9C1F12}" dt="2025-12-18T21:22:34.717" v="397" actId="20577"/>
-        <pc:sldMkLst>
-          <pc:docMk/>
-          <pc:sldMk cId="1659504250" sldId="505"/>
-        </pc:sldMkLst>
-        <pc:spChg chg="mod">
-          <ac:chgData name="Matthieu De Mari" userId="dfb708c9-d8dc-439f-9a3b-c772bf4a311c" providerId="ADAL" clId="{81E9B007-0C2C-493E-9B93-55A62C9C1F12}" dt="2025-12-18T21:22:34.717" v="397" actId="20577"/>
-          <ac:spMkLst>
-            <pc:docMk/>
-            <pc:sldMk cId="1659504250" sldId="505"/>
-            <ac:spMk id="6" creationId="{035BA096-4E67-B5D5-DBD3-F226777FADC7}"/>
-          </ac:spMkLst>
-        </pc:spChg>
-      </pc:sldChg>
-      <pc:sldChg chg="modSp mod">
-        <pc:chgData name="Matthieu De Mari" userId="dfb708c9-d8dc-439f-9a3b-c772bf4a311c" providerId="ADAL" clId="{81E9B007-0C2C-493E-9B93-55A62C9C1F12}" dt="2026-01-08T10:16:13.475" v="934"/>
-        <pc:sldMkLst>
-          <pc:docMk/>
-          <pc:sldMk cId="3495317520" sldId="508"/>
-        </pc:sldMkLst>
-        <pc:spChg chg="mod">
-          <ac:chgData name="Matthieu De Mari" userId="dfb708c9-d8dc-439f-9a3b-c772bf4a311c" providerId="ADAL" clId="{81E9B007-0C2C-493E-9B93-55A62C9C1F12}" dt="2026-01-08T10:16:13.475" v="934"/>
-          <ac:spMkLst>
-            <pc:docMk/>
-            <pc:sldMk cId="3495317520" sldId="508"/>
-            <ac:spMk id="3" creationId="{7BDE96C0-465C-7952-04EA-C267AC8BF678}"/>
-          </ac:spMkLst>
-        </pc:spChg>
-        <pc:spChg chg="mod">
-          <ac:chgData name="Matthieu De Mari" userId="dfb708c9-d8dc-439f-9a3b-c772bf4a311c" providerId="ADAL" clId="{81E9B007-0C2C-493E-9B93-55A62C9C1F12}" dt="2025-12-18T21:19:19.861" v="331" actId="20577"/>
-          <ac:spMkLst>
-            <pc:docMk/>
-            <pc:sldMk cId="3495317520" sldId="508"/>
-            <ac:spMk id="4" creationId="{5E76589E-870E-419D-CF95-4309EACDB190}"/>
-          </ac:spMkLst>
-        </pc:spChg>
-      </pc:sldChg>
-      <pc:sldChg chg="del">
-        <pc:chgData name="Matthieu De Mari" userId="dfb708c9-d8dc-439f-9a3b-c772bf4a311c" providerId="ADAL" clId="{81E9B007-0C2C-493E-9B93-55A62C9C1F12}" dt="2026-01-08T10:04:55.199" v="412" actId="47"/>
-        <pc:sldMkLst>
-          <pc:docMk/>
-          <pc:sldMk cId="1464669599" sldId="517"/>
-        </pc:sldMkLst>
-      </pc:sldChg>
-      <pc:sldChg chg="del">
-        <pc:chgData name="Matthieu De Mari" userId="dfb708c9-d8dc-439f-9a3b-c772bf4a311c" providerId="ADAL" clId="{81E9B007-0C2C-493E-9B93-55A62C9C1F12}" dt="2026-01-08T10:04:56.750" v="413" actId="47"/>
-        <pc:sldMkLst>
-          <pc:docMk/>
-          <pc:sldMk cId="3190584464" sldId="518"/>
-        </pc:sldMkLst>
-      </pc:sldChg>
-      <pc:sldChg chg="modSp del mod">
-        <pc:chgData name="Matthieu De Mari" userId="dfb708c9-d8dc-439f-9a3b-c772bf4a311c" providerId="ADAL" clId="{81E9B007-0C2C-493E-9B93-55A62C9C1F12}" dt="2026-01-08T10:08:17.791" v="520" actId="47"/>
-        <pc:sldMkLst>
-          <pc:docMk/>
-          <pc:sldMk cId="434677060" sldId="534"/>
-        </pc:sldMkLst>
-        <pc:spChg chg="mod">
-          <ac:chgData name="Matthieu De Mari" userId="dfb708c9-d8dc-439f-9a3b-c772bf4a311c" providerId="ADAL" clId="{81E9B007-0C2C-493E-9B93-55A62C9C1F12}" dt="2026-01-08T10:08:03.758" v="519" actId="20577"/>
-          <ac:spMkLst>
-            <pc:docMk/>
-            <pc:sldMk cId="434677060" sldId="534"/>
-            <ac:spMk id="5" creationId="{6D84BCCB-A835-F94C-CAC7-2175BFC0AEB5}"/>
-          </ac:spMkLst>
-        </pc:spChg>
-      </pc:sldChg>
-      <pc:sldChg chg="modSp mod">
-        <pc:chgData name="Matthieu De Mari" userId="dfb708c9-d8dc-439f-9a3b-c772bf4a311c" providerId="ADAL" clId="{81E9B007-0C2C-493E-9B93-55A62C9C1F12}" dt="2026-01-08T10:12:45.148" v="792" actId="20577"/>
+        <pc:chgData name="Matthieu De Mari" userId="dfb708c9-d8dc-439f-9a3b-c772bf4a311c" providerId="ADAL" clId="{81E9B007-0C2C-493E-9B93-55A62C9C1F12}" dt="2026-03-15T14:21:09.923" v="981" actId="113"/>
         <pc:sldMkLst>
           <pc:docMk/>
           <pc:sldMk cId="3487424720" sldId="536"/>
         </pc:sldMkLst>
         <pc:spChg chg="mod">
-          <ac:chgData name="Matthieu De Mari" userId="dfb708c9-d8dc-439f-9a3b-c772bf4a311c" providerId="ADAL" clId="{81E9B007-0C2C-493E-9B93-55A62C9C1F12}" dt="2026-01-08T10:12:45.148" v="792" actId="20577"/>
+          <ac:chgData name="Matthieu De Mari" userId="dfb708c9-d8dc-439f-9a3b-c772bf4a311c" providerId="ADAL" clId="{81E9B007-0C2C-493E-9B93-55A62C9C1F12}" dt="2026-03-15T14:21:09.923" v="981" actId="113"/>
           <ac:spMkLst>
             <pc:docMk/>
             <pc:sldMk cId="3487424720" sldId="536"/>
             <ac:spMk id="2" creationId="{37C84060-31A2-3AFB-B38D-81D7652356D5}"/>
-          </ac:spMkLst>
-        </pc:spChg>
-        <pc:spChg chg="mod">
-          <ac:chgData name="Matthieu De Mari" userId="dfb708c9-d8dc-439f-9a3b-c772bf4a311c" providerId="ADAL" clId="{81E9B007-0C2C-493E-9B93-55A62C9C1F12}" dt="2025-12-18T21:15:15.108" v="270"/>
-          <ac:spMkLst>
-            <pc:docMk/>
-            <pc:sldMk cId="3487424720" sldId="536"/>
-            <ac:spMk id="6" creationId="{3FF27FA6-234D-EB6E-7AD4-4E52F151A639}"/>
-          </ac:spMkLst>
-        </pc:spChg>
-      </pc:sldChg>
-      <pc:sldChg chg="modSp mod">
-        <pc:chgData name="Matthieu De Mari" userId="dfb708c9-d8dc-439f-9a3b-c772bf4a311c" providerId="ADAL" clId="{81E9B007-0C2C-493E-9B93-55A62C9C1F12}" dt="2025-12-18T21:17:52.069" v="277" actId="20577"/>
-        <pc:sldMkLst>
-          <pc:docMk/>
-          <pc:sldMk cId="2224169310" sldId="537"/>
-        </pc:sldMkLst>
-        <pc:spChg chg="mod">
-          <ac:chgData name="Matthieu De Mari" userId="dfb708c9-d8dc-439f-9a3b-c772bf4a311c" providerId="ADAL" clId="{81E9B007-0C2C-493E-9B93-55A62C9C1F12}" dt="2025-12-18T21:17:52.069" v="277" actId="20577"/>
-          <ac:spMkLst>
-            <pc:docMk/>
-            <pc:sldMk cId="2224169310" sldId="537"/>
-            <ac:spMk id="3" creationId="{99FBFDD0-6F31-1CFE-48D3-44BF5F1483C3}"/>
-          </ac:spMkLst>
-        </pc:spChg>
-      </pc:sldChg>
-      <pc:sldChg chg="modSp">
-        <pc:chgData name="Matthieu De Mari" userId="dfb708c9-d8dc-439f-9a3b-c772bf4a311c" providerId="ADAL" clId="{81E9B007-0C2C-493E-9B93-55A62C9C1F12}" dt="2025-12-18T21:22:09.969" v="390"/>
-        <pc:sldMkLst>
-          <pc:docMk/>
-          <pc:sldMk cId="1671560902" sldId="538"/>
-        </pc:sldMkLst>
-        <pc:spChg chg="mod">
-          <ac:chgData name="Matthieu De Mari" userId="dfb708c9-d8dc-439f-9a3b-c772bf4a311c" providerId="ADAL" clId="{81E9B007-0C2C-493E-9B93-55A62C9C1F12}" dt="2025-12-18T21:22:09.969" v="390"/>
-          <ac:spMkLst>
-            <pc:docMk/>
-            <pc:sldMk cId="1671560902" sldId="538"/>
-            <ac:spMk id="2" creationId="{7E8004EF-5A8C-5081-A7AD-65F92DB1C7E9}"/>
-          </ac:spMkLst>
-        </pc:spChg>
-      </pc:sldChg>
-      <pc:sldChg chg="add">
-        <pc:chgData name="Matthieu De Mari" userId="dfb708c9-d8dc-439f-9a3b-c772bf4a311c" providerId="ADAL" clId="{81E9B007-0C2C-493E-9B93-55A62C9C1F12}" dt="2025-12-18T21:15:01.636" v="263"/>
-        <pc:sldMkLst>
-          <pc:docMk/>
-          <pc:sldMk cId="1061347991" sldId="539"/>
-        </pc:sldMkLst>
-      </pc:sldChg>
-      <pc:sldChg chg="modSp add mod">
-        <pc:chgData name="Matthieu De Mari" userId="dfb708c9-d8dc-439f-9a3b-c772bf4a311c" providerId="ADAL" clId="{81E9B007-0C2C-493E-9B93-55A62C9C1F12}" dt="2026-01-08T10:18:08.699" v="938" actId="20577"/>
-        <pc:sldMkLst>
-          <pc:docMk/>
-          <pc:sldMk cId="4272836236" sldId="548"/>
-        </pc:sldMkLst>
-        <pc:spChg chg="mod">
-          <ac:chgData name="Matthieu De Mari" userId="dfb708c9-d8dc-439f-9a3b-c772bf4a311c" providerId="ADAL" clId="{81E9B007-0C2C-493E-9B93-55A62C9C1F12}" dt="2026-01-08T10:18:08.699" v="938" actId="20577"/>
-          <ac:spMkLst>
-            <pc:docMk/>
-            <pc:sldMk cId="4272836236" sldId="548"/>
-            <ac:spMk id="5" creationId="{8784BD3C-A362-227F-DB67-10CF1E267B66}"/>
           </ac:spMkLst>
         </pc:spChg>
       </pc:sldChg>
@@ -834,7 +366,7 @@
           <a:p>
             <a:fld id="{61478373-EB31-4867-8CF0-FA31364748A5}" type="datetimeFigureOut">
               <a:rPr lang="en-GB" smtClean="0"/>
-              <a:t>09/01/2026</a:t>
+              <a:t>15/03/2026</a:t>
             </a:fld>
             <a:endParaRPr lang="en-GB"/>
           </a:p>
@@ -1251,7 +783,7 @@
           <a:p>
             <a:fld id="{E85DF616-B21E-4EF6-A6A5-95E2FB3EB1A1}" type="datetimeFigureOut">
               <a:rPr lang="en-GB" smtClean="0"/>
-              <a:t>09/01/2026</a:t>
+              <a:t>15/03/2026</a:t>
             </a:fld>
             <a:endParaRPr lang="en-GB"/>
           </a:p>
@@ -1451,7 +983,7 @@
           <a:p>
             <a:fld id="{E85DF616-B21E-4EF6-A6A5-95E2FB3EB1A1}" type="datetimeFigureOut">
               <a:rPr lang="en-GB" smtClean="0"/>
-              <a:t>09/01/2026</a:t>
+              <a:t>15/03/2026</a:t>
             </a:fld>
             <a:endParaRPr lang="en-GB"/>
           </a:p>
@@ -1661,7 +1193,7 @@
           <a:p>
             <a:fld id="{E85DF616-B21E-4EF6-A6A5-95E2FB3EB1A1}" type="datetimeFigureOut">
               <a:rPr lang="en-GB" smtClean="0"/>
-              <a:t>09/01/2026</a:t>
+              <a:t>15/03/2026</a:t>
             </a:fld>
             <a:endParaRPr lang="en-GB"/>
           </a:p>
@@ -1861,7 +1393,7 @@
           <a:p>
             <a:fld id="{E85DF616-B21E-4EF6-A6A5-95E2FB3EB1A1}" type="datetimeFigureOut">
               <a:rPr lang="en-GB" smtClean="0"/>
-              <a:t>09/01/2026</a:t>
+              <a:t>15/03/2026</a:t>
             </a:fld>
             <a:endParaRPr lang="en-GB"/>
           </a:p>
@@ -2137,7 +1669,7 @@
           <a:p>
             <a:fld id="{E85DF616-B21E-4EF6-A6A5-95E2FB3EB1A1}" type="datetimeFigureOut">
               <a:rPr lang="en-GB" smtClean="0"/>
-              <a:t>09/01/2026</a:t>
+              <a:t>15/03/2026</a:t>
             </a:fld>
             <a:endParaRPr lang="en-GB"/>
           </a:p>
@@ -2405,7 +1937,7 @@
           <a:p>
             <a:fld id="{E85DF616-B21E-4EF6-A6A5-95E2FB3EB1A1}" type="datetimeFigureOut">
               <a:rPr lang="en-GB" smtClean="0"/>
-              <a:t>09/01/2026</a:t>
+              <a:t>15/03/2026</a:t>
             </a:fld>
             <a:endParaRPr lang="en-GB"/>
           </a:p>
@@ -2820,7 +2352,7 @@
           <a:p>
             <a:fld id="{E85DF616-B21E-4EF6-A6A5-95E2FB3EB1A1}" type="datetimeFigureOut">
               <a:rPr lang="en-GB" smtClean="0"/>
-              <a:t>09/01/2026</a:t>
+              <a:t>15/03/2026</a:t>
             </a:fld>
             <a:endParaRPr lang="en-GB"/>
           </a:p>
@@ -2962,7 +2494,7 @@
           <a:p>
             <a:fld id="{E85DF616-B21E-4EF6-A6A5-95E2FB3EB1A1}" type="datetimeFigureOut">
               <a:rPr lang="en-GB" smtClean="0"/>
-              <a:t>09/01/2026</a:t>
+              <a:t>15/03/2026</a:t>
             </a:fld>
             <a:endParaRPr lang="en-GB"/>
           </a:p>
@@ -3075,7 +2607,7 @@
           <a:p>
             <a:fld id="{E85DF616-B21E-4EF6-A6A5-95E2FB3EB1A1}" type="datetimeFigureOut">
               <a:rPr lang="en-GB" smtClean="0"/>
-              <a:t>09/01/2026</a:t>
+              <a:t>15/03/2026</a:t>
             </a:fld>
             <a:endParaRPr lang="en-GB"/>
           </a:p>
@@ -3388,7 +2920,7 @@
           <a:p>
             <a:fld id="{E85DF616-B21E-4EF6-A6A5-95E2FB3EB1A1}" type="datetimeFigureOut">
               <a:rPr lang="en-GB" smtClean="0"/>
-              <a:t>09/01/2026</a:t>
+              <a:t>15/03/2026</a:t>
             </a:fld>
             <a:endParaRPr lang="en-GB"/>
           </a:p>
@@ -3677,7 +3209,7 @@
           <a:p>
             <a:fld id="{E85DF616-B21E-4EF6-A6A5-95E2FB3EB1A1}" type="datetimeFigureOut">
               <a:rPr lang="en-GB" smtClean="0"/>
-              <a:t>09/01/2026</a:t>
+              <a:t>15/03/2026</a:t>
             </a:fld>
             <a:endParaRPr lang="en-GB"/>
           </a:p>
@@ -3920,7 +3452,7 @@
           <a:p>
             <a:fld id="{E85DF616-B21E-4EF6-A6A5-95E2FB3EB1A1}" type="datetimeFigureOut">
               <a:rPr lang="en-GB" smtClean="0"/>
-              <a:t>09/01/2026</a:t>
+              <a:t>15/03/2026</a:t>
             </a:fld>
             <a:endParaRPr lang="en-GB"/>
           </a:p>
@@ -6449,220 +5981,8 @@
           </a:p>
         </p:txBody>
       </p:sp>
-      <p:sp>
-        <p:nvSpPr>
-          <p:cNvPr id="2" name="Content Placeholder 1">
-            <a:extLst>
-              <a:ext uri="{FF2B5EF4-FFF2-40B4-BE49-F238E27FC236}">
-                <a16:creationId xmlns:a16="http://schemas.microsoft.com/office/drawing/2014/main" id="{37C84060-31A2-3AFB-B38D-81D7652356D5}"/>
-              </a:ext>
-            </a:extLst>
-          </p:cNvPr>
-          <p:cNvSpPr>
-            <a:spLocks noGrp="1"/>
-          </p:cNvSpPr>
-          <p:nvPr>
-            <p:ph sz="half" idx="2"/>
-          </p:nvPr>
-        </p:nvSpPr>
-        <p:spPr>
-          <a:xfrm>
-            <a:off x="6172199" y="1825624"/>
-            <a:ext cx="5807279" cy="5032375"/>
-          </a:xfrm>
-        </p:spPr>
-        <p:txBody>
-          <a:bodyPr>
-            <a:normAutofit/>
-          </a:bodyPr>
-          <a:lstStyle/>
-          <a:p>
-            <a:pPr marL="0" indent="0">
-              <a:buNone/>
-            </a:pPr>
-            <a:r>
-              <a:rPr lang="en-GB" dirty="0"/>
-              <a:t>This typically happens when</a:t>
-            </a:r>
-          </a:p>
-          <a:p>
-            <a:r>
-              <a:rPr lang="en-GB" dirty="0"/>
-              <a:t>a model has too many parameters compared to what the dataset would need,</a:t>
-            </a:r>
-          </a:p>
-          <a:p>
-            <a:r>
-              <a:rPr lang="en-GB" dirty="0"/>
-              <a:t>or there is imbalance in the data.</a:t>
-            </a:r>
-          </a:p>
-          <a:p>
-            <a:pPr marL="0" indent="0">
-              <a:buNone/>
-            </a:pPr>
-            <a:r>
-              <a:rPr lang="en-GB" dirty="0"/>
-              <a:t>The model might then struggle to </a:t>
-            </a:r>
-            <a:r>
-              <a:rPr lang="en-GB" b="1" dirty="0">
-                <a:solidFill>
-                  <a:srgbClr val="7030A0"/>
-                </a:solidFill>
-              </a:rPr>
-              <a:t>generalize</a:t>
-            </a:r>
-            <a:r>
-              <a:rPr lang="en-GB" dirty="0"/>
-              <a:t> to new unseen data.</a:t>
-            </a:r>
-          </a:p>
-          <a:p>
-            <a:pPr marL="0" indent="0">
-              <a:buNone/>
-            </a:pPr>
-            <a:r>
-              <a:rPr lang="en-GB" dirty="0"/>
-              <a:t>In other words, it memorizes the noise in the dataset rather than learning the correct underlying pattern, and makes awkward predictions</a:t>
-            </a:r>
-            <a:endParaRPr lang="en-SG" dirty="0"/>
-          </a:p>
-        </p:txBody>
-      </p:sp>
-    </p:spTree>
-    <p:extLst>
-      <p:ext uri="{BB962C8B-B14F-4D97-AF65-F5344CB8AC3E}">
-        <p14:creationId xmlns:p14="http://schemas.microsoft.com/office/powerpoint/2010/main" val="1974002731"/>
-      </p:ext>
-    </p:extLst>
-  </p:cSld>
-  <p:clrMapOvr>
-    <a:masterClrMapping/>
-  </p:clrMapOvr>
-</p:sld>
-</file>
-
-<file path=ppt/slides/slide19.xml><?xml version="1.0" encoding="utf-8"?>
-<p:sld xmlns:a="http://schemas.openxmlformats.org/drawingml/2006/main" xmlns:r="http://schemas.openxmlformats.org/officeDocument/2006/relationships" xmlns:p="http://schemas.openxmlformats.org/presentationml/2006/main">
-  <p:cSld>
-    <p:spTree>
-      <p:nvGrpSpPr>
-        <p:cNvPr id="1" name=""/>
-        <p:cNvGrpSpPr/>
-        <p:nvPr/>
-      </p:nvGrpSpPr>
-      <p:grpSpPr>
-        <a:xfrm>
-          <a:off x="0" y="0"/>
-          <a:ext cx="0" cy="0"/>
-          <a:chOff x="0" y="0"/>
-          <a:chExt cx="0" cy="0"/>
-        </a:xfrm>
-      </p:grpSpPr>
-      <p:sp>
-        <p:nvSpPr>
-          <p:cNvPr id="5" name="Title 4">
-            <a:extLst>
-              <a:ext uri="{FF2B5EF4-FFF2-40B4-BE49-F238E27FC236}">
-                <a16:creationId xmlns:a16="http://schemas.microsoft.com/office/drawing/2014/main" id="{BC884000-0FC9-A696-A696-8635960E124E}"/>
-              </a:ext>
-            </a:extLst>
-          </p:cNvPr>
-          <p:cNvSpPr>
-            <a:spLocks noGrp="1"/>
-          </p:cNvSpPr>
-          <p:nvPr>
-            <p:ph type="title"/>
-          </p:nvPr>
-        </p:nvSpPr>
-        <p:spPr/>
-        <p:txBody>
-          <a:bodyPr/>
-          <a:lstStyle/>
-          <a:p>
-            <a:r>
-              <a:rPr lang="en-GB" dirty="0"/>
-              <a:t>Overfitting vs. degree of polynomial</a:t>
-            </a:r>
-            <a:endParaRPr lang="en-SG" dirty="0"/>
-          </a:p>
-        </p:txBody>
-      </p:sp>
-      <p:sp>
-        <p:nvSpPr>
-          <p:cNvPr id="6" name="Content Placeholder 5">
-            <a:extLst>
-              <a:ext uri="{FF2B5EF4-FFF2-40B4-BE49-F238E27FC236}">
-                <a16:creationId xmlns:a16="http://schemas.microsoft.com/office/drawing/2014/main" id="{3FF27FA6-234D-EB6E-7AD4-4E52F151A639}"/>
-              </a:ext>
-            </a:extLst>
-          </p:cNvPr>
-          <p:cNvSpPr>
-            <a:spLocks noGrp="1"/>
-          </p:cNvSpPr>
-          <p:nvPr>
-            <p:ph sz="half" idx="1"/>
-          </p:nvPr>
-        </p:nvSpPr>
-        <p:spPr/>
-        <p:txBody>
-          <a:bodyPr>
-            <a:normAutofit/>
-          </a:bodyPr>
-          <a:lstStyle/>
-          <a:p>
-            <a:pPr marL="0" indent="0">
-              <a:buNone/>
-            </a:pPr>
-            <a:r>
-              <a:rPr lang="en-GB" b="1" dirty="0"/>
-              <a:t>Definition (</a:t>
-            </a:r>
-            <a:r>
-              <a:rPr lang="en-GB" b="1" dirty="0">
-                <a:solidFill>
-                  <a:srgbClr val="00B050"/>
-                </a:solidFill>
-              </a:rPr>
-              <a:t>Overfitting</a:t>
-            </a:r>
-            <a:r>
-              <a:rPr lang="en-GB" b="1" dirty="0"/>
-              <a:t>):</a:t>
-            </a:r>
-          </a:p>
-          <a:p>
-            <a:pPr marL="0" indent="0">
-              <a:buNone/>
-            </a:pPr>
-            <a:r>
-              <a:rPr lang="en-GB" b="1" dirty="0">
-                <a:solidFill>
-                  <a:srgbClr val="00B050"/>
-                </a:solidFill>
-              </a:rPr>
-              <a:t>Overfitting</a:t>
-            </a:r>
-            <a:r>
-              <a:rPr lang="en-GB" dirty="0"/>
-              <a:t> is a phenomenon that occurs in machine learning when a model is trained too well on the training data.</a:t>
-            </a:r>
-          </a:p>
-          <a:p>
-            <a:pPr marL="0" indent="0">
-              <a:buNone/>
-            </a:pPr>
-            <a:r>
-              <a:rPr lang="en-GB" dirty="0"/>
-              <a:t>As a result, it may perform poorly on new, unseen data (here an apartment with 150sqm surface, which was not present in the training dataset).</a:t>
-            </a:r>
-            <a:endParaRPr lang="en-SG" dirty="0"/>
-          </a:p>
-        </p:txBody>
-      </p:sp>
-      <mc:AlternateContent xmlns:mc="http://schemas.openxmlformats.org/markup-compatibility/2006" xmlns:a14="http://schemas.microsoft.com/office/drawing/2010/main">
-        <mc:Choice Requires="a14">
+      <mc:AlternateContent xmlns:mc="http://schemas.openxmlformats.org/markup-compatibility/2006">
+        <mc:Choice xmlns:a14="http://schemas.microsoft.com/office/drawing/2010/main" Requires="a14">
           <p:sp>
             <p:nvSpPr>
               <p:cNvPr id="2" name="Content Placeholder 1">
@@ -6695,7 +6015,7 @@
                   <a:buNone/>
                 </a:pPr>
                 <a:r>
-                  <a:rPr lang="en-GB" dirty="0"/>
+                  <a:rPr lang="en-GB" b="1" dirty="0"/>
                   <a:t>This typically happens if the model complexity is too high compared to the dataset complexity.</a:t>
                 </a:r>
               </a:p>
@@ -6732,7 +6052,7 @@
             </p:txBody>
           </p:sp>
         </mc:Choice>
-        <mc:Fallback xmlns="">
+        <mc:Fallback>
           <p:sp>
             <p:nvSpPr>
               <p:cNvPr id="2" name="Content Placeholder 1">
@@ -6757,7 +6077,7 @@
               <a:blipFill>
                 <a:blip r:embed="rId2"/>
                 <a:stretch>
-                  <a:fillRect l="-2471" t="-1937" r="-3882"/>
+                  <a:fillRect l="-2471" t="-1937" r="-2471"/>
                 </a:stretch>
               </a:blipFill>
             </p:spPr>
@@ -6780,6 +6100,218 @@
     <p:extLst>
       <p:ext uri="{BB962C8B-B14F-4D97-AF65-F5344CB8AC3E}">
         <p14:creationId xmlns:p14="http://schemas.microsoft.com/office/powerpoint/2010/main" val="3487424720"/>
+      </p:ext>
+    </p:extLst>
+  </p:cSld>
+  <p:clrMapOvr>
+    <a:masterClrMapping/>
+  </p:clrMapOvr>
+</p:sld>
+</file>
+
+<file path=ppt/slides/slide19.xml><?xml version="1.0" encoding="utf-8"?>
+<p:sld xmlns:a="http://schemas.openxmlformats.org/drawingml/2006/main" xmlns:r="http://schemas.openxmlformats.org/officeDocument/2006/relationships" xmlns:p="http://schemas.openxmlformats.org/presentationml/2006/main">
+  <p:cSld>
+    <p:spTree>
+      <p:nvGrpSpPr>
+        <p:cNvPr id="1" name=""/>
+        <p:cNvGrpSpPr/>
+        <p:nvPr/>
+      </p:nvGrpSpPr>
+      <p:grpSpPr>
+        <a:xfrm>
+          <a:off x="0" y="0"/>
+          <a:ext cx="0" cy="0"/>
+          <a:chOff x="0" y="0"/>
+          <a:chExt cx="0" cy="0"/>
+        </a:xfrm>
+      </p:grpSpPr>
+      <p:sp>
+        <p:nvSpPr>
+          <p:cNvPr id="5" name="Title 4">
+            <a:extLst>
+              <a:ext uri="{FF2B5EF4-FFF2-40B4-BE49-F238E27FC236}">
+                <a16:creationId xmlns:a16="http://schemas.microsoft.com/office/drawing/2014/main" id="{BC884000-0FC9-A696-A696-8635960E124E}"/>
+              </a:ext>
+            </a:extLst>
+          </p:cNvPr>
+          <p:cNvSpPr>
+            <a:spLocks noGrp="1"/>
+          </p:cNvSpPr>
+          <p:nvPr>
+            <p:ph type="title"/>
+          </p:nvPr>
+        </p:nvSpPr>
+        <p:spPr/>
+        <p:txBody>
+          <a:bodyPr/>
+          <a:lstStyle/>
+          <a:p>
+            <a:r>
+              <a:rPr lang="en-GB" dirty="0"/>
+              <a:t>Overfitting vs. degree of polynomial</a:t>
+            </a:r>
+            <a:endParaRPr lang="en-SG" dirty="0"/>
+          </a:p>
+        </p:txBody>
+      </p:sp>
+      <p:sp>
+        <p:nvSpPr>
+          <p:cNvPr id="6" name="Content Placeholder 5">
+            <a:extLst>
+              <a:ext uri="{FF2B5EF4-FFF2-40B4-BE49-F238E27FC236}">
+                <a16:creationId xmlns:a16="http://schemas.microsoft.com/office/drawing/2014/main" id="{3FF27FA6-234D-EB6E-7AD4-4E52F151A639}"/>
+              </a:ext>
+            </a:extLst>
+          </p:cNvPr>
+          <p:cNvSpPr>
+            <a:spLocks noGrp="1"/>
+          </p:cNvSpPr>
+          <p:nvPr>
+            <p:ph sz="half" idx="1"/>
+          </p:nvPr>
+        </p:nvSpPr>
+        <p:spPr/>
+        <p:txBody>
+          <a:bodyPr>
+            <a:normAutofit/>
+          </a:bodyPr>
+          <a:lstStyle/>
+          <a:p>
+            <a:pPr marL="0" indent="0">
+              <a:buNone/>
+            </a:pPr>
+            <a:r>
+              <a:rPr lang="en-GB" b="1" dirty="0"/>
+              <a:t>Definition (</a:t>
+            </a:r>
+            <a:r>
+              <a:rPr lang="en-GB" b="1" dirty="0">
+                <a:solidFill>
+                  <a:srgbClr val="00B050"/>
+                </a:solidFill>
+              </a:rPr>
+              <a:t>Overfitting</a:t>
+            </a:r>
+            <a:r>
+              <a:rPr lang="en-GB" b="1" dirty="0"/>
+              <a:t>):</a:t>
+            </a:r>
+          </a:p>
+          <a:p>
+            <a:pPr marL="0" indent="0">
+              <a:buNone/>
+            </a:pPr>
+            <a:r>
+              <a:rPr lang="en-GB" b="1" dirty="0">
+                <a:solidFill>
+                  <a:srgbClr val="00B050"/>
+                </a:solidFill>
+              </a:rPr>
+              <a:t>Overfitting</a:t>
+            </a:r>
+            <a:r>
+              <a:rPr lang="en-GB" dirty="0"/>
+              <a:t> is a phenomenon that occurs in machine learning when a model is trained too well on the training data.</a:t>
+            </a:r>
+          </a:p>
+          <a:p>
+            <a:pPr marL="0" indent="0">
+              <a:buNone/>
+            </a:pPr>
+            <a:r>
+              <a:rPr lang="en-GB" dirty="0"/>
+              <a:t>As a result, it may perform poorly on new, unseen data (here an apartment with 150sqm surface, which was not present in the training dataset).</a:t>
+            </a:r>
+            <a:endParaRPr lang="en-SG" dirty="0"/>
+          </a:p>
+        </p:txBody>
+      </p:sp>
+      <p:sp>
+        <p:nvSpPr>
+          <p:cNvPr id="2" name="Content Placeholder 1">
+            <a:extLst>
+              <a:ext uri="{FF2B5EF4-FFF2-40B4-BE49-F238E27FC236}">
+                <a16:creationId xmlns:a16="http://schemas.microsoft.com/office/drawing/2014/main" id="{37C84060-31A2-3AFB-B38D-81D7652356D5}"/>
+              </a:ext>
+            </a:extLst>
+          </p:cNvPr>
+          <p:cNvSpPr>
+            <a:spLocks noGrp="1"/>
+          </p:cNvSpPr>
+          <p:nvPr>
+            <p:ph sz="half" idx="2"/>
+          </p:nvPr>
+        </p:nvSpPr>
+        <p:spPr>
+          <a:xfrm>
+            <a:off x="6172199" y="1825624"/>
+            <a:ext cx="5807279" cy="5032375"/>
+          </a:xfrm>
+        </p:spPr>
+        <p:txBody>
+          <a:bodyPr>
+            <a:normAutofit/>
+          </a:bodyPr>
+          <a:lstStyle/>
+          <a:p>
+            <a:pPr marL="0" indent="0">
+              <a:buNone/>
+            </a:pPr>
+            <a:r>
+              <a:rPr lang="en-GB" dirty="0"/>
+              <a:t>This typically happens when</a:t>
+            </a:r>
+          </a:p>
+          <a:p>
+            <a:r>
+              <a:rPr lang="en-GB" dirty="0"/>
+              <a:t>a model is too complex for the dataset, i.e. it has too many parameters compared to what the dataset would need,</a:t>
+            </a:r>
+          </a:p>
+          <a:p>
+            <a:r>
+              <a:rPr lang="en-GB" dirty="0"/>
+              <a:t>or there is imbalance in the data.</a:t>
+            </a:r>
+          </a:p>
+          <a:p>
+            <a:pPr marL="0" indent="0">
+              <a:buNone/>
+            </a:pPr>
+            <a:endParaRPr lang="en-GB" dirty="0"/>
+          </a:p>
+          <a:p>
+            <a:pPr marL="0" indent="0">
+              <a:buNone/>
+            </a:pPr>
+            <a:r>
+              <a:rPr lang="en-GB"/>
+              <a:t>As a consequence</a:t>
+            </a:r>
+            <a:r>
+              <a:rPr lang="en-GB" dirty="0"/>
+              <a:t>, the model might then struggle to </a:t>
+            </a:r>
+            <a:r>
+              <a:rPr lang="en-GB" b="1" dirty="0">
+                <a:solidFill>
+                  <a:srgbClr val="7030A0"/>
+                </a:solidFill>
+              </a:rPr>
+              <a:t>generalize</a:t>
+            </a:r>
+            <a:r>
+              <a:rPr lang="en-GB" dirty="0"/>
+              <a:t> to new unseen data.</a:t>
+            </a:r>
+          </a:p>
+        </p:txBody>
+      </p:sp>
+    </p:spTree>
+    <p:extLst>
+      <p:ext uri="{BB962C8B-B14F-4D97-AF65-F5344CB8AC3E}">
+        <p14:creationId xmlns:p14="http://schemas.microsoft.com/office/powerpoint/2010/main" val="1974002731"/>
       </p:ext>
     </p:extLst>
   </p:cSld>

</xml_diff>